<commit_message>
fix: corriger 9 KPIs → 15 KPIs dans la présentation et CLAUDE.md
</commit_message>
<xml_diff>
--- a/docs/MediCore_Presentation.pptx
+++ b/docs/MediCore_Presentation.pptx
@@ -1214,7 +1214,7 @@
           <a:p/>
           <a:p>
             <a:r>
-              <a:t>Les 9 KPIs couvrent les principaux axes d'analyse. Notamment le KPI opérateur (fact_operateur) qui mesure la performance de chaque vendeur en pharmacie via le nombre de ventes, panier moyen, CA généré. C'est un levier managérial concret : le titulaire peut identifier ses meilleurs vendeurs et adapter ses formations.</a:t>
+              <a:t>Les 15 KPIs couvrent les principaux axes d'analyse. Notamment le KPI opérateur (fact_operateur) qui mesure la performance de chaque vendeur en pharmacie via le nombre de ventes, panier moyen, CA généré. C'est un levier managérial concret : le titulaire peut identifier ses meilleurs vendeurs et adapter ses formations.</a:t>
             </a:r>
           </a:p>
           <a:p/>
@@ -1857,7 +1857,7 @@
           <a:lstStyle/>
           <a:p>
             <a:r>
-              <a:t>À gauche, tout ce qui est implémenté et fonctionnel. Le pipeline complet ingère les 18 tables, le star schema produit 3 dim, 8 faits et 9 KPIs, le CDC tourne en temps réel, le batch Bulk load tourne quotidiennement, le masquage PII est automatique, le lineage audit trace chaque exécution, et le CI/CD déploie automatiquement.</a:t>
+              <a:t>À gauche, tout ce qui est implémenté et fonctionnel. Le pipeline complet ingère les 18 tables, le star schema produit 3 dim, 8 faits et 15 KPIs, le CDC tourne en temps réel, le batch Bulk load tourne quotidiennement, le masquage PII est automatique, le lineage audit trace chaque exécution, et le CI/CD déploie automatiquement.</a:t>
             </a:r>
           </a:p>
           <a:p/>
@@ -2414,7 +2414,7 @@
           </a:p>
           <a:p>
             <a:r>
-              <a:t>Les modèles marts (ou GOLD) construisent le star schema pour donner en sortie 3 DIM, 8 FAITS et 9 KPIs.</a:t>
+              <a:t>Les modèles marts (ou GOLD) construisent le star schema pour donner en sortie 3 DIM, 8 FAITS et 15 KPIs.</a:t>
             </a:r>
           </a:p>
           <a:p/>
@@ -7908,7 +7908,7 @@
                   <a:srgbClr val="C8102E"/>
                 </a:solidFill>
               </a:rPr>
-              <a:t>9 KPIs métier  :</a:t>
+              <a:t>15 KPIs métier  :</a:t>
             </a:r>
             <a:r>
               <a:rPr sz="1800">
@@ -10065,7 +10065,7 @@
                   <a:srgbClr val="2D2D2D"/>
                 </a:solidFill>
               </a:rPr>
-              <a:t> 3 dim, 8 faits, 9 KPIs</a:t>
+              <a:t> 3 dim, 8 faits, 15 KPIs</a:t>
             </a:r>
           </a:p>
           <a:p>
@@ -13434,7 +13434,7 @@
               </a:defRPr>
             </a:pPr>
             <a:r>
-              <a:t>9 KPIs</a:t>
+              <a:t>15 KPIs</a:t>
             </a:r>
           </a:p>
         </p:txBody>

</xml_diff>